<commit_message>
Update Customer Churn project live demo URL and refresh slides
Co-Authored-By: Claude Sonnet 4.6 <noreply@anthropic.com>
</commit_message>
<xml_diff>
--- a/Customer_Churn_Final.pptx
+++ b/Customer_Churn_Final.pptx
@@ -7620,7 +7620,7 @@
                 <a:latin typeface="Trebuchet MS" pitchFamily="34" charset="0"/>
                 <a:hlinkClick r:id="rId2"/>
               </a:rPr>
-              <a:t>bayesian-dashboard-303092178542.us-central1.run.app</a:t>
+              <a:t>bayesian-dashboard-128505233033.us-central1.run.app</a:t>
             </a:r>
           </a:p>
         </p:txBody>
@@ -7763,7 +7763,7 @@
                 </a:solidFill>
                 <a:latin typeface="Calibri" pitchFamily="34" charset="0"/>
               </a:rPr>
-              <a:t>Deployed on Google Cloud Run (GCP). Containerised via Docker. Auto-scaling serverless architecture. Zero-downtime updates. Procfile + requirements.txt for reproducibility.</a:t>
+              <a:t>Deployed on Google Cloud Run (GCP). Containerised via Docker (python:3.9-slim). Built with Cloud Build (amd64). Auto-scaling serverless. Zero-downtime rollback via revision history.</a:t>
             </a:r>
           </a:p>
         </p:txBody>
@@ -8117,7 +8117,7 @@
                 </a:solidFill>
                 <a:latin typeface="Calibri" pitchFamily="34" charset="0"/>
               </a:rPr>
-              <a:t>Deployment scripts in Phase_5_Deployment_guide/  ·  Dockerfile + Cloud Run config  ·  Demo: https://bayesian-dashboard-303092178542.us-central1.run.app/</a:t>
+              <a:t>Deployment protocol in Phase_5_Depolyment guide/DEPLOYMENT.md  ·  Dockerfile + Cloud Build config  ·  Demo: https://bayesian-dashboard-128505233033.us-central1.run.app/</a:t>
             </a:r>
           </a:p>
         </p:txBody>

</xml_diff>